<commit_message>
Sjöskolan: presentationer, bildspel och lärarguide genereras ur innehållsdatabasen
Övnings- och stödbilder, start- och avslutsfrågor, arbetsbladens och seminariets bilder skrivs ur posterna med
bevarad formatering; PDF:er konverteras med LibreOffice och webbildspelen byggs om. Lärarguidens facit räknas
för D = 1–31 ur registrerade funktioner och låses med lärarlösenordet. Veckosidorna läser inlämningsrubrikerna
ur det publika id-registret.

Co-Authored-By: Claude Fable 5.1 <noreply@anthropic.com>
Claude-Session: https://claude.ai/code/session_011V9KjBb53XrDm23Dw58SH3
</commit_message>
<xml_diff>
--- a/sjoskolan/vecka-37/aktuell/v37_04_Elsakerhet_och_riskbedomning_elev.pptx
+++ b/sjoskolan/vecka-37/aktuell/v37_04_Elsakerhet_och_riskbedomning_elev.pptx
@@ -8794,7 +8794,7 @@
                 <a:ea typeface="Calibri"/>
                 <a:cs typeface="Calibri"/>
               </a:rPr>
-              <a:t>E3: Fyll i nästa riskrad</a:t>
+              <a:t>E3: Mörk gångväg</a:t>
             </a:r>
           </a:p>
         </p:txBody>
@@ -9592,7 +9592,7 @@
                 <a:ea typeface="Calibri"/>
                 <a:cs typeface="Calibri"/>
               </a:rPr>
-              <a:t>E4: Ett meddelande som går fram</a:t>
+              <a:t>E4: Tydligt meddelande</a:t>
             </a:r>
           </a:p>
         </p:txBody>
@@ -11985,7 +11985,7 @@
                 <a:ea typeface="Calibri"/>
                 <a:cs typeface="Calibri"/>
               </a:rPr>
-              <a:t>E5: Välj och motivera</a:t>
+              <a:t>E5: Reservlampor</a:t>
             </a:r>
           </a:p>
         </p:txBody>
@@ -13323,7 +13323,7 @@
                 <a:ea typeface="Calibri"/>
                 <a:cs typeface="Calibri"/>
               </a:rPr>
-              <a:t>E6: Din riskbedömning</a:t>
+              <a:t>E6: Egen riskbedömning</a:t>
             </a:r>
           </a:p>
         </p:txBody>
@@ -13597,7 +13597,7 @@
                 <a:ea typeface="Calibri"/>
                 <a:cs typeface="Calibri"/>
               </a:rPr>
-              <a:t>E7: Granska en kamrats beslut</a:t>
+              <a:t>E7: Kamratgranskning</a:t>
             </a:r>
           </a:p>
         </p:txBody>
@@ -14693,7 +14693,7 @@
                 <a:ea typeface="Calibri"/>
                 <a:cs typeface="Calibri"/>
               </a:rPr>
-              <a:t>E8: En egen slutsats</a:t>
+              <a:t>E8: Egen slutsats</a:t>
             </a:r>
           </a:p>
         </p:txBody>

</xml_diff>